<commit_message>
Slides v3. WIP 2
</commit_message>
<xml_diff>
--- a/06_relazioni_e_parametri/Slides_v3/12_vqe-approssimazione-stato-fondamentale.pptx
+++ b/06_relazioni_e_parametri/Slides_v3/12_vqe-approssimazione-stato-fondamentale.pptx
@@ -8,7 +8,7 @@
     <p:notesMasterId r:id="rId3"/>
   </p:notesMasterIdLst>
   <p:sldIdLst>
-    <p:sldId id="256" r:id="rId2"/>
+    <p:sldId id="280" r:id="rId2"/>
   </p:sldIdLst>
   <p:sldSz cx="12192000" cy="6858000"/>
   <p:notesSz cx="6858000" cy="12192000"/>
@@ -635,15 +635,7 @@
 
 <file path=ppt/slides/slide1.xml><?xml version="1.0" encoding="utf-8"?>
 <p:sld xmlns:a="http://schemas.openxmlformats.org/drawingml/2006/main" xmlns:r="http://schemas.openxmlformats.org/officeDocument/2006/relationships" xmlns:p="http://schemas.openxmlformats.org/presentationml/2006/main">
-  <p:cSld name="Slide 1">
-    <p:bg>
-      <p:bgPr>
-        <a:solidFill>
-          <a:srgbClr val="FFFFFF"/>
-        </a:solidFill>
-        <a:effectLst/>
-      </p:bgPr>
-    </p:bg>
+  <p:cSld>
     <p:spTree>
       <p:nvGrpSpPr>
         <p:cNvPr id="1" name=""/>
@@ -725,7 +717,7 @@
           <a:lstStyle/>
           <a:p>
             <a:r>
-              <a:rPr lang="en-US" sz="3800" b="1" dirty="0" err="1">
+              <a:rPr lang="en-US" sz="3600" b="1" dirty="0" err="1">
                 <a:solidFill>
                   <a:srgbClr val="16233A"/>
                 </a:solidFill>
@@ -736,7 +728,7 @@
               <a:t>Simulazione</a:t>
             </a:r>
             <a:r>
-              <a:rPr lang="en-US" sz="3800" b="1" dirty="0">
+              <a:rPr lang="en-US" sz="3600" b="1" dirty="0">
                 <a:solidFill>
                   <a:srgbClr val="16233A"/>
                 </a:solidFill>
@@ -747,7 +739,7 @@
               <a:t> </a:t>
             </a:r>
             <a:r>
-              <a:rPr lang="en-US" sz="3800" b="1" dirty="0" err="1">
+              <a:rPr lang="en-US" sz="3600" b="1" dirty="0" err="1">
                 <a:solidFill>
                   <a:srgbClr val="16233A"/>
                 </a:solidFill>
@@ -755,9 +747,9 @@
                 <a:ea typeface="Calibri" pitchFamily="34" charset="-122"/>
                 <a:cs typeface="Calibri" pitchFamily="34" charset="-120"/>
               </a:rPr>
-              <a:t>statica</a:t>
+              <a:t>Statica</a:t>
             </a:r>
-            <a:endParaRPr lang="en-US" sz="3800" dirty="0"/>
+            <a:endParaRPr lang="en-US" sz="3600" dirty="0"/>
           </a:p>
         </p:txBody>
       </p:sp>
@@ -777,14 +769,13 @@
         </p:nvPicPr>
         <p:blipFill>
           <a:blip r:embed="rId3"/>
-          <a:stretch>
-            <a:fillRect/>
-          </a:stretch>
+          <a:srcRect/>
+          <a:stretch/>
         </p:blipFill>
         <p:spPr>
           <a:xfrm>
-            <a:off x="309708" y="2148840"/>
-            <a:ext cx="4652992" cy="3393948"/>
+            <a:off x="382411" y="2148840"/>
+            <a:ext cx="4507586" cy="3393948"/>
           </a:xfrm>
           <a:prstGeom prst="rect">
             <a:avLst/>
@@ -805,7 +796,7 @@
         </p:nvSpPr>
         <p:spPr>
           <a:xfrm>
-            <a:off x="640080" y="1554480"/>
+            <a:off x="652779" y="1490472"/>
             <a:ext cx="10911535" cy="530352"/>
           </a:xfrm>
           <a:prstGeom prst="roundRect">
@@ -840,7 +831,7 @@
         </p:nvSpPr>
         <p:spPr>
           <a:xfrm>
-            <a:off x="640079" y="1554480"/>
+            <a:off x="652778" y="1490472"/>
             <a:ext cx="10911535" cy="530352"/>
           </a:xfrm>
           <a:prstGeom prst="rect">
@@ -855,7 +846,7 @@
           <a:p>
             <a:pPr algn="ctr"/>
             <a:r>
-              <a:rPr lang="en-US" sz="2100" b="1" dirty="0">
+              <a:rPr lang="en-US" sz="2100" b="1" i="1" dirty="0">
                 <a:solidFill>
                   <a:srgbClr val="173A5E"/>
                 </a:solidFill>
@@ -866,7 +857,7 @@
               <a:t>Livelli di </a:t>
             </a:r>
             <a:r>
-              <a:rPr lang="en-US" sz="2100" b="1" dirty="0" err="1">
+              <a:rPr lang="en-US" sz="2100" b="1" i="1" dirty="0" err="1">
                 <a:solidFill>
                   <a:srgbClr val="173A5E"/>
                 </a:solidFill>
@@ -877,7 +868,7 @@
               <a:t>energia</a:t>
             </a:r>
             <a:r>
-              <a:rPr lang="en-US" sz="2100" b="1" dirty="0">
+              <a:rPr lang="en-US" sz="2100" b="1" i="1" dirty="0">
                 <a:solidFill>
                   <a:srgbClr val="173A5E"/>
                 </a:solidFill>
@@ -888,7 +879,7 @@
               <a:t>, </a:t>
             </a:r>
             <a:r>
-              <a:rPr lang="en-US" sz="2100" b="1" dirty="0" err="1">
+              <a:rPr lang="en-US" sz="2100" b="1" i="1" dirty="0" err="1">
                 <a:solidFill>
                   <a:srgbClr val="173A5E"/>
                 </a:solidFill>
@@ -899,7 +890,7 @@
               <a:t>approssimazione</a:t>
             </a:r>
             <a:r>
-              <a:rPr lang="en-US" sz="2100" b="1" dirty="0">
+              <a:rPr lang="en-US" sz="2100" b="1" i="1" dirty="0">
                 <a:solidFill>
                   <a:srgbClr val="173A5E"/>
                 </a:solidFill>
@@ -909,7 +900,7 @@
               </a:rPr>
               <a:t> VQE e gap</a:t>
             </a:r>
-            <a:endParaRPr lang="en-US" sz="2100" dirty="0"/>
+            <a:endParaRPr lang="en-US" sz="2100" i="1" dirty="0"/>
           </a:p>
         </p:txBody>
       </p:sp>
@@ -929,14 +920,13 @@
         </p:nvPicPr>
         <p:blipFill>
           <a:blip r:embed="rId4"/>
-          <a:stretch>
-            <a:fillRect/>
-          </a:stretch>
+          <a:srcRect/>
+          <a:stretch/>
         </p:blipFill>
         <p:spPr>
           <a:xfrm>
-            <a:off x="6559337" y="2148840"/>
-            <a:ext cx="4652992" cy="3393947"/>
+            <a:off x="6700337" y="2148840"/>
+            <a:ext cx="4370992" cy="3393946"/>
           </a:xfrm>
           <a:prstGeom prst="rect">
             <a:avLst/>
@@ -955,59 +945,53 @@
           <p:cNvGraphicFramePr>
             <a:graphicFrameLocks noGrp="1"/>
           </p:cNvGraphicFramePr>
-          <p:nvPr>
-            <p:extLst>
-              <p:ext uri="{D42A27DB-BD31-4B8C-83A1-F6EECF244321}">
-                <p14:modId xmlns:p14="http://schemas.microsoft.com/office/powerpoint/2010/main" val="1682938296"/>
-              </p:ext>
-            </p:extLst>
-          </p:nvPr>
+          <p:nvPr/>
         </p:nvGraphicFramePr>
         <p:xfrm>
-          <a:off x="6175046" y="5542788"/>
-          <a:ext cx="5389267" cy="1203960"/>
+          <a:off x="6126481" y="5542788"/>
+          <a:ext cx="5437829" cy="1203960"/>
         </p:xfrm>
         <a:graphic>
           <a:graphicData uri="http://schemas.openxmlformats.org/drawingml/2006/table">
             <a:tbl>
               <a:tblPr/>
               <a:tblGrid>
-                <a:gridCol w="587115">
+                <a:gridCol w="592406">
                   <a:extLst>
                     <a:ext uri="{9D8B030D-6E8A-4147-A177-3AD203B41FA5}">
                       <a16:colId xmlns:a16="http://schemas.microsoft.com/office/drawing/2014/main" val="20000"/>
                     </a:ext>
                   </a:extLst>
                 </a:gridCol>
-                <a:gridCol w="496790">
+                <a:gridCol w="501266">
                   <a:extLst>
                     <a:ext uri="{9D8B030D-6E8A-4147-A177-3AD203B41FA5}">
                       <a16:colId xmlns:a16="http://schemas.microsoft.com/office/drawing/2014/main" val="20001"/>
                     </a:ext>
                   </a:extLst>
                 </a:gridCol>
-                <a:gridCol w="496790">
+                <a:gridCol w="501266">
                   <a:extLst>
                     <a:ext uri="{9D8B030D-6E8A-4147-A177-3AD203B41FA5}">
                       <a16:colId xmlns:a16="http://schemas.microsoft.com/office/drawing/2014/main" val="20002"/>
                     </a:ext>
                   </a:extLst>
                 </a:gridCol>
-                <a:gridCol w="903254">
+                <a:gridCol w="911393">
                   <a:extLst>
                     <a:ext uri="{9D8B030D-6E8A-4147-A177-3AD203B41FA5}">
                       <a16:colId xmlns:a16="http://schemas.microsoft.com/office/drawing/2014/main" val="20003"/>
                     </a:ext>
                   </a:extLst>
                 </a:gridCol>
-                <a:gridCol w="1174231">
+                <a:gridCol w="1184812">
                   <a:extLst>
                     <a:ext uri="{9D8B030D-6E8A-4147-A177-3AD203B41FA5}">
                       <a16:colId xmlns:a16="http://schemas.microsoft.com/office/drawing/2014/main" val="20004"/>
                     </a:ext>
                   </a:extLst>
                 </a:gridCol>
-                <a:gridCol w="1731087">
+                <a:gridCol w="1746686">
                   <a:extLst>
                     <a:ext uri="{9D8B030D-6E8A-4147-A177-3AD203B41FA5}">
                       <a16:colId xmlns:a16="http://schemas.microsoft.com/office/drawing/2014/main" val="20005"/>
@@ -1237,7 +1221,7 @@
                           <a:ea typeface="Calibri" pitchFamily="34" charset="-122"/>
                           <a:cs typeface="Calibri" pitchFamily="34" charset="-120"/>
                         </a:rPr>
-                        <a:t>Energia</a:t>
+                        <a:t>Energia (b=0)</a:t>
                       </a:r>
                       <a:endParaRPr lang="en-US" sz="1100" dirty="0">
                         <a:latin typeface="Calibri" charset="0"/>
@@ -2691,52 +2675,46 @@
           <p:cNvGraphicFramePr>
             <a:graphicFrameLocks noGrp="1"/>
           </p:cNvGraphicFramePr>
-          <p:nvPr>
-            <p:extLst>
-              <p:ext uri="{D42A27DB-BD31-4B8C-83A1-F6EECF244321}">
-                <p14:modId xmlns:p14="http://schemas.microsoft.com/office/powerpoint/2010/main" val="37267761"/>
-              </p:ext>
-            </p:extLst>
-          </p:nvPr>
+          <p:nvPr/>
         </p:nvGraphicFramePr>
         <p:xfrm>
           <a:off x="498764" y="5542788"/>
-          <a:ext cx="4605250" cy="1203960"/>
+          <a:ext cx="4381243" cy="1203960"/>
         </p:xfrm>
         <a:graphic>
           <a:graphicData uri="http://schemas.openxmlformats.org/drawingml/2006/table">
             <a:tbl>
               <a:tblPr/>
               <a:tblGrid>
-                <a:gridCol w="849036">
+                <a:gridCol w="807738">
                   <a:extLst>
                     <a:ext uri="{9D8B030D-6E8A-4147-A177-3AD203B41FA5}">
                       <a16:colId xmlns:a16="http://schemas.microsoft.com/office/drawing/2014/main" val="20000"/>
                     </a:ext>
                   </a:extLst>
                 </a:gridCol>
-                <a:gridCol w="501703">
+                <a:gridCol w="477299">
                   <a:extLst>
                     <a:ext uri="{9D8B030D-6E8A-4147-A177-3AD203B41FA5}">
                       <a16:colId xmlns:a16="http://schemas.microsoft.com/office/drawing/2014/main" val="20001"/>
                     </a:ext>
                   </a:extLst>
                 </a:gridCol>
-                <a:gridCol w="926222">
+                <a:gridCol w="881169">
                   <a:extLst>
                     <a:ext uri="{9D8B030D-6E8A-4147-A177-3AD203B41FA5}">
                       <a16:colId xmlns:a16="http://schemas.microsoft.com/office/drawing/2014/main" val="20002"/>
                     </a:ext>
                   </a:extLst>
                 </a:gridCol>
-                <a:gridCol w="1016142">
+                <a:gridCol w="966715">
                   <a:extLst>
                     <a:ext uri="{9D8B030D-6E8A-4147-A177-3AD203B41FA5}">
                       <a16:colId xmlns:a16="http://schemas.microsoft.com/office/drawing/2014/main" val="20003"/>
                     </a:ext>
                   </a:extLst>
                 </a:gridCol>
-                <a:gridCol w="1312147">
+                <a:gridCol w="1248322">
                   <a:extLst>
                     <a:ext uri="{9D8B030D-6E8A-4147-A177-3AD203B41FA5}">
                       <a16:colId xmlns:a16="http://schemas.microsoft.com/office/drawing/2014/main" val="20004"/>
@@ -3789,8 +3767,8 @@
           </a:graphicData>
         </a:graphic>
       </p:graphicFrame>
-      <mc:AlternateContent xmlns:mc="http://schemas.openxmlformats.org/markup-compatibility/2006">
-        <mc:Choice xmlns:a14="http://schemas.microsoft.com/office/drawing/2010/main" Requires="a14">
+      <mc:AlternateContent xmlns:mc="http://schemas.openxmlformats.org/markup-compatibility/2006" xmlns:a14="http://schemas.microsoft.com/office/drawing/2010/main">
+        <mc:Choice Requires="a14">
           <p:sp>
             <p:nvSpPr>
               <p:cNvPr id="33" name="TextBox 32">
@@ -3806,7 +3784,7 @@
             <p:spPr>
               <a:xfrm>
                 <a:off x="4962700" y="2577353"/>
-                <a:ext cx="1596637" cy="2292935"/>
+                <a:ext cx="1596637" cy="2462213"/>
               </a:xfrm>
               <a:prstGeom prst="rect">
                 <a:avLst/>
@@ -3913,7 +3891,15 @@
                 </a:r>
                 <a:r>
                   <a:rPr lang="en-US" sz="1100" dirty="0"/>
-                  <a:t> il DM fosse </a:t>
+                  <a:t> il </a:t>
+                </a:r>
+                <a:r>
+                  <a:rPr lang="en-US" sz="1100" dirty="0" err="1"/>
+                  <a:t>termine</a:t>
+                </a:r>
+                <a:r>
+                  <a:rPr lang="en-US" sz="1100" dirty="0"/>
+                  <a:t> DM fosse </a:t>
                 </a:r>
                 <a:r>
                   <a:rPr lang="en-US" sz="1100" dirty="0" err="1"/>
@@ -3982,19 +3968,27 @@
                 <a14:m>
                   <m:oMath xmlns:m="http://schemas.openxmlformats.org/officeDocument/2006/math">
                     <m:r>
-                      <a:rPr lang="en-US" sz="1100" i="1"/>
+                      <a:rPr lang="en-US" sz="1100" i="1">
+                        <a:latin typeface="Cambria Math" panose="02040503050406030204" pitchFamily="18" charset="0"/>
+                      </a:rPr>
                       <m:t>𝑏</m:t>
                     </m:r>
                     <m:r>
-                      <a:rPr lang="en-US" sz="1100"/>
+                      <a:rPr lang="en-US" sz="1100">
+                        <a:latin typeface="Cambria Math" panose="02040503050406030204" pitchFamily="18" charset="0"/>
+                      </a:rPr>
                       <m:t>/</m:t>
                     </m:r>
                     <m:r>
-                      <a:rPr lang="en-US" sz="1100" i="1"/>
+                      <a:rPr lang="en-US" sz="1100" i="1">
+                        <a:latin typeface="Cambria Math" panose="02040503050406030204" pitchFamily="18" charset="0"/>
+                      </a:rPr>
                       <m:t>𝐽</m:t>
                     </m:r>
                     <m:r>
-                      <a:rPr lang="en-US" sz="1100"/>
+                      <a:rPr lang="en-US" sz="1100">
+                        <a:latin typeface="Cambria Math" panose="02040503050406030204" pitchFamily="18" charset="0"/>
+                      </a:rPr>
                       <m:t>=</m:t>
                     </m:r>
                     <m:r>
@@ -4012,7 +4006,9 @@
                 <a14:m>
                   <m:oMath xmlns:m="http://schemas.openxmlformats.org/officeDocument/2006/math">
                     <m:r>
-                      <a:rPr lang="en-US" sz="1100"/>
+                      <a:rPr lang="en-US" sz="1100">
+                        <a:latin typeface="Cambria Math" panose="02040503050406030204" pitchFamily="18" charset="0"/>
+                      </a:rPr>
                       <m:t>2.07</m:t>
                     </m:r>
                   </m:oMath>
@@ -4056,7 +4052,9 @@
                       <m:t>𝐽</m:t>
                     </m:r>
                     <m:r>
-                      <a:rPr lang="en-US" sz="1100"/>
+                      <a:rPr lang="en-US" sz="1100">
+                        <a:latin typeface="Cambria Math" panose="02040503050406030204" pitchFamily="18" charset="0"/>
+                      </a:rPr>
                       <m:t>=2.4</m:t>
                     </m:r>
                   </m:oMath>
@@ -4068,7 +4066,9 @@
                 <a14:m>
                   <m:oMath xmlns:m="http://schemas.openxmlformats.org/officeDocument/2006/math">
                     <m:r>
-                      <a:rPr lang="en-US" sz="1100"/>
+                      <a:rPr lang="en-US" sz="1100">
+                        <a:latin typeface="Cambria Math" panose="02040503050406030204" pitchFamily="18" charset="0"/>
+                      </a:rPr>
                       <m:t>2.41</m:t>
                     </m:r>
                   </m:oMath>
@@ -4081,7 +4081,7 @@
             </p:txBody>
           </p:sp>
         </mc:Choice>
-        <mc:Fallback>
+        <mc:Fallback xmlns="">
           <p:sp>
             <p:nvSpPr>
               <p:cNvPr id="33" name="TextBox 32">
@@ -4099,7 +4099,7 @@
             <p:spPr>
               <a:xfrm>
                 <a:off x="4962700" y="2577353"/>
-                <a:ext cx="1596637" cy="2292935"/>
+                <a:ext cx="1596637" cy="2462213"/>
               </a:xfrm>
               <a:prstGeom prst="rect">
                 <a:avLst/>
@@ -4107,7 +4107,7 @@
               <a:blipFill>
                 <a:blip r:embed="rId5"/>
                 <a:stretch>
-                  <a:fillRect t="-266" r="-1908" b="-1064"/>
+                  <a:fillRect t="-248" r="-1908" b="-743"/>
                 </a:stretch>
               </a:blipFill>
             </p:spPr>

</xml_diff>